<commit_message>
added the 3 slides for the Brainhack presentation
</commit_message>
<xml_diff>
--- a/comparison_images/slides_axdki.pptx
+++ b/comparison_images/slides_axdki.pptx
@@ -15,6 +15,9 @@
     <p:sldId id="264" r:id="rId9"/>
     <p:sldId id="266" r:id="rId10"/>
     <p:sldId id="267" r:id="rId11"/>
+    <p:sldId id="268" r:id="rId12"/>
+    <p:sldId id="270" r:id="rId13"/>
+    <p:sldId id="272" r:id="rId14"/>
   </p:sldIdLst>
   <p:sldSz cx="12192000" cy="6858000"/>
   <p:notesSz cx="6858000" cy="9144000"/>
@@ -119,7 +122,7 @@
 <file path=ppt/revisionInfo.xml><?xml version="1.0" encoding="utf-8"?>
 <p1510:revInfo xmlns:a="http://schemas.openxmlformats.org/drawingml/2006/main" xmlns:r="http://schemas.openxmlformats.org/officeDocument/2006/relationships" xmlns:p1510="http://schemas.microsoft.com/office/powerpoint/2015/10/main">
   <p1510:revLst>
-    <p1510:client id="{86104CC2-197B-4CA6-BBAD-E6724CF0FBC0}" v="41" dt="2026-03-29T21:03:39.861"/>
+    <p1510:client id="{86104CC2-197B-4CA6-BBAD-E6724CF0FBC0}" v="43" dt="2026-03-29T21:23:55.652"/>
   </p1510:revLst>
 </p1510:revInfo>
 </file>
@@ -129,7 +132,7 @@
   <pc:docChgLst>
     <pc:chgData name="Víctor Issa García" userId="8e09f2137b4f6074" providerId="LiveId" clId="{3CAB8FB7-30D4-4B0A-B34F-79343C8F4340}"/>
     <pc:docChg chg="undo custSel addSld delSld modSld sldOrd">
-      <pc:chgData name="Víctor Issa García" userId="8e09f2137b4f6074" providerId="LiveId" clId="{3CAB8FB7-30D4-4B0A-B34F-79343C8F4340}" dt="2026-03-29T21:03:39.861" v="189"/>
+      <pc:chgData name="Víctor Issa García" userId="8e09f2137b4f6074" providerId="LiveId" clId="{3CAB8FB7-30D4-4B0A-B34F-79343C8F4340}" dt="2026-03-29T21:24:14.848" v="301" actId="478"/>
       <pc:docMkLst>
         <pc:docMk/>
       </pc:docMkLst>
@@ -986,6 +989,233 @@
             <ac:picMk id="23" creationId="{F54B75B6-5B18-E550-9783-CE8F9B918FC0}"/>
           </ac:picMkLst>
         </pc:picChg>
+      </pc:sldChg>
+      <pc:sldChg chg="addSp delSp modSp new mod">
+        <pc:chgData name="Víctor Issa García" userId="8e09f2137b4f6074" providerId="LiveId" clId="{3CAB8FB7-30D4-4B0A-B34F-79343C8F4340}" dt="2026-03-29T21:21:13.314" v="286" actId="14100"/>
+        <pc:sldMkLst>
+          <pc:docMk/>
+          <pc:sldMk cId="2985895534" sldId="268"/>
+        </pc:sldMkLst>
+        <pc:spChg chg="add del">
+          <ac:chgData name="Víctor Issa García" userId="8e09f2137b4f6074" providerId="LiveId" clId="{3CAB8FB7-30D4-4B0A-B34F-79343C8F4340}" dt="2026-03-29T21:15:13.762" v="212" actId="478"/>
+          <ac:spMkLst>
+            <pc:docMk/>
+            <pc:sldMk cId="2985895534" sldId="268"/>
+            <ac:spMk id="3" creationId="{27BB22A3-6ACE-FDC1-477D-4CD5EE6E0720}"/>
+          </ac:spMkLst>
+        </pc:spChg>
+        <pc:picChg chg="add del mod ord">
+          <ac:chgData name="Víctor Issa García" userId="8e09f2137b4f6074" providerId="LiveId" clId="{3CAB8FB7-30D4-4B0A-B34F-79343C8F4340}" dt="2026-03-29T21:14:53.979" v="196" actId="931"/>
+          <ac:picMkLst>
+            <pc:docMk/>
+            <pc:sldMk cId="2985895534" sldId="268"/>
+            <ac:picMk id="5" creationId="{B3654BEE-2360-4CD0-A11E-90535D1E8D4C}"/>
+          </ac:picMkLst>
+        </pc:picChg>
+        <pc:picChg chg="add del mod">
+          <ac:chgData name="Víctor Issa García" userId="8e09f2137b4f6074" providerId="LiveId" clId="{3CAB8FB7-30D4-4B0A-B34F-79343C8F4340}" dt="2026-03-29T21:14:53.431" v="195" actId="931"/>
+          <ac:picMkLst>
+            <pc:docMk/>
+            <pc:sldMk cId="2985895534" sldId="268"/>
+            <ac:picMk id="7" creationId="{37410851-E284-404C-C7F6-D45D3F1783B8}"/>
+          </ac:picMkLst>
+        </pc:picChg>
+        <pc:picChg chg="add del mod ord">
+          <ac:chgData name="Víctor Issa García" userId="8e09f2137b4f6074" providerId="LiveId" clId="{3CAB8FB7-30D4-4B0A-B34F-79343C8F4340}" dt="2026-03-29T21:14:59.085" v="199" actId="931"/>
+          <ac:picMkLst>
+            <pc:docMk/>
+            <pc:sldMk cId="2985895534" sldId="268"/>
+            <ac:picMk id="9" creationId="{4982E083-B5BF-5DDF-0AE5-ED3EE494D5E5}"/>
+          </ac:picMkLst>
+        </pc:picChg>
+        <pc:picChg chg="add del mod ord">
+          <ac:chgData name="Víctor Issa García" userId="8e09f2137b4f6074" providerId="LiveId" clId="{3CAB8FB7-30D4-4B0A-B34F-79343C8F4340}" dt="2026-03-29T21:15:01.382" v="202" actId="931"/>
+          <ac:picMkLst>
+            <pc:docMk/>
+            <pc:sldMk cId="2985895534" sldId="268"/>
+            <ac:picMk id="11" creationId="{CBE9D029-C8A0-EE11-2A4E-94FA910431BC}"/>
+          </ac:picMkLst>
+        </pc:picChg>
+        <pc:picChg chg="add del mod ord">
+          <ac:chgData name="Víctor Issa García" userId="8e09f2137b4f6074" providerId="LiveId" clId="{3CAB8FB7-30D4-4B0A-B34F-79343C8F4340}" dt="2026-03-29T21:15:08.177" v="205" actId="931"/>
+          <ac:picMkLst>
+            <pc:docMk/>
+            <pc:sldMk cId="2985895534" sldId="268"/>
+            <ac:picMk id="13" creationId="{BC9542D6-0553-65F9-8511-EE8F71E14D7D}"/>
+          </ac:picMkLst>
+        </pc:picChg>
+        <pc:picChg chg="add del mod ord">
+          <ac:chgData name="Víctor Issa García" userId="8e09f2137b4f6074" providerId="LiveId" clId="{3CAB8FB7-30D4-4B0A-B34F-79343C8F4340}" dt="2026-03-29T21:15:09.978" v="208" actId="931"/>
+          <ac:picMkLst>
+            <pc:docMk/>
+            <pc:sldMk cId="2985895534" sldId="268"/>
+            <ac:picMk id="15" creationId="{32EC0587-9EF3-2EF4-7436-914C1DD52596}"/>
+          </ac:picMkLst>
+        </pc:picChg>
+        <pc:picChg chg="add del mod ord">
+          <ac:chgData name="Víctor Issa García" userId="8e09f2137b4f6074" providerId="LiveId" clId="{3CAB8FB7-30D4-4B0A-B34F-79343C8F4340}" dt="2026-03-29T21:15:11.509" v="211" actId="931"/>
+          <ac:picMkLst>
+            <pc:docMk/>
+            <pc:sldMk cId="2985895534" sldId="268"/>
+            <ac:picMk id="17" creationId="{E505B986-6356-F572-80ED-F89464F5FC48}"/>
+          </ac:picMkLst>
+        </pc:picChg>
+        <pc:picChg chg="add mod modCrop">
+          <ac:chgData name="Víctor Issa García" userId="8e09f2137b4f6074" providerId="LiveId" clId="{3CAB8FB7-30D4-4B0A-B34F-79343C8F4340}" dt="2026-03-29T21:21:00.032" v="285" actId="1076"/>
+          <ac:picMkLst>
+            <pc:docMk/>
+            <pc:sldMk cId="2985895534" sldId="268"/>
+            <ac:picMk id="19" creationId="{12F6FD37-1893-1BA7-F482-54CB081A55B0}"/>
+          </ac:picMkLst>
+        </pc:picChg>
+        <pc:picChg chg="add mod modCrop">
+          <ac:chgData name="Víctor Issa García" userId="8e09f2137b4f6074" providerId="LiveId" clId="{3CAB8FB7-30D4-4B0A-B34F-79343C8F4340}" dt="2026-03-29T21:21:00.032" v="285" actId="1076"/>
+          <ac:picMkLst>
+            <pc:docMk/>
+            <pc:sldMk cId="2985895534" sldId="268"/>
+            <ac:picMk id="21" creationId="{0AC8E1AE-5225-51D7-C286-CB2774B6A2DB}"/>
+          </ac:picMkLst>
+        </pc:picChg>
+        <pc:picChg chg="add mod modCrop">
+          <ac:chgData name="Víctor Issa García" userId="8e09f2137b4f6074" providerId="LiveId" clId="{3CAB8FB7-30D4-4B0A-B34F-79343C8F4340}" dt="2026-03-29T21:21:00.032" v="285" actId="1076"/>
+          <ac:picMkLst>
+            <pc:docMk/>
+            <pc:sldMk cId="2985895534" sldId="268"/>
+            <ac:picMk id="23" creationId="{6F78FBAF-EC5C-7871-A8C3-626E404ADC53}"/>
+          </ac:picMkLst>
+        </pc:picChg>
+        <pc:picChg chg="add del mod modCrop">
+          <ac:chgData name="Víctor Issa García" userId="8e09f2137b4f6074" providerId="LiveId" clId="{3CAB8FB7-30D4-4B0A-B34F-79343C8F4340}" dt="2026-03-29T21:20:49.071" v="283" actId="478"/>
+          <ac:picMkLst>
+            <pc:docMk/>
+            <pc:sldMk cId="2985895534" sldId="268"/>
+            <ac:picMk id="25" creationId="{D16E6538-5197-42EA-FDF0-F00A85C1D355}"/>
+          </ac:picMkLst>
+        </pc:picChg>
+        <pc:picChg chg="add mod modCrop">
+          <ac:chgData name="Víctor Issa García" userId="8e09f2137b4f6074" providerId="LiveId" clId="{3CAB8FB7-30D4-4B0A-B34F-79343C8F4340}" dt="2026-03-29T21:21:00.032" v="285" actId="1076"/>
+          <ac:picMkLst>
+            <pc:docMk/>
+            <pc:sldMk cId="2985895534" sldId="268"/>
+            <ac:picMk id="27" creationId="{E756990E-3B42-0458-273F-E5455A9DAB4D}"/>
+          </ac:picMkLst>
+        </pc:picChg>
+        <pc:picChg chg="add mod modCrop">
+          <ac:chgData name="Víctor Issa García" userId="8e09f2137b4f6074" providerId="LiveId" clId="{3CAB8FB7-30D4-4B0A-B34F-79343C8F4340}" dt="2026-03-29T21:21:00.032" v="285" actId="1076"/>
+          <ac:picMkLst>
+            <pc:docMk/>
+            <pc:sldMk cId="2985895534" sldId="268"/>
+            <ac:picMk id="29" creationId="{9253CE9F-69E0-6386-F73A-F15B4846F69D}"/>
+          </ac:picMkLst>
+        </pc:picChg>
+        <pc:picChg chg="add mod modCrop">
+          <ac:chgData name="Víctor Issa García" userId="8e09f2137b4f6074" providerId="LiveId" clId="{3CAB8FB7-30D4-4B0A-B34F-79343C8F4340}" dt="2026-03-29T21:21:13.314" v="286" actId="14100"/>
+          <ac:picMkLst>
+            <pc:docMk/>
+            <pc:sldMk cId="2985895534" sldId="268"/>
+            <ac:picMk id="31" creationId="{86DB7AA0-4E41-1765-C100-E47509EE4AC9}"/>
+          </ac:picMkLst>
+        </pc:picChg>
+        <pc:picChg chg="add del mod modCrop">
+          <ac:chgData name="Víctor Issa García" userId="8e09f2137b4f6074" providerId="LiveId" clId="{3CAB8FB7-30D4-4B0A-B34F-79343C8F4340}" dt="2026-03-29T21:20:49.626" v="284" actId="478"/>
+          <ac:picMkLst>
+            <pc:docMk/>
+            <pc:sldMk cId="2985895534" sldId="268"/>
+            <ac:picMk id="33" creationId="{1F4784C2-5B55-935C-C6DB-1AD2763BB59C}"/>
+          </ac:picMkLst>
+        </pc:picChg>
+        <pc:picChg chg="add del mod modCrop">
+          <ac:chgData name="Víctor Issa García" userId="8e09f2137b4f6074" providerId="LiveId" clId="{3CAB8FB7-30D4-4B0A-B34F-79343C8F4340}" dt="2026-03-29T21:20:42.620" v="282" actId="478"/>
+          <ac:picMkLst>
+            <pc:docMk/>
+            <pc:sldMk cId="2985895534" sldId="268"/>
+            <ac:picMk id="35" creationId="{A9A9E813-CE27-A72F-A00B-18BA0E1A135D}"/>
+          </ac:picMkLst>
+        </pc:picChg>
+      </pc:sldChg>
+      <pc:sldChg chg="new del">
+        <pc:chgData name="Víctor Issa García" userId="8e09f2137b4f6074" providerId="LiveId" clId="{3CAB8FB7-30D4-4B0A-B34F-79343C8F4340}" dt="2026-03-29T21:21:43.766" v="289" actId="47"/>
+        <pc:sldMkLst>
+          <pc:docMk/>
+          <pc:sldMk cId="3423447516" sldId="269"/>
+        </pc:sldMkLst>
+      </pc:sldChg>
+      <pc:sldChg chg="modSp add mod">
+        <pc:chgData name="Víctor Issa García" userId="8e09f2137b4f6074" providerId="LiveId" clId="{3CAB8FB7-30D4-4B0A-B34F-79343C8F4340}" dt="2026-03-29T21:22:48.895" v="297" actId="1076"/>
+        <pc:sldMkLst>
+          <pc:docMk/>
+          <pc:sldMk cId="2882937987" sldId="270"/>
+        </pc:sldMkLst>
+        <pc:picChg chg="mod modCrop">
+          <ac:chgData name="Víctor Issa García" userId="8e09f2137b4f6074" providerId="LiveId" clId="{3CAB8FB7-30D4-4B0A-B34F-79343C8F4340}" dt="2026-03-29T21:21:53.043" v="290" actId="18131"/>
+          <ac:picMkLst>
+            <pc:docMk/>
+            <pc:sldMk cId="2882937987" sldId="270"/>
+            <ac:picMk id="19" creationId="{81D66F95-BA91-1151-33C6-A24229929B32}"/>
+          </ac:picMkLst>
+        </pc:picChg>
+        <pc:picChg chg="mod modCrop">
+          <ac:chgData name="Víctor Issa García" userId="8e09f2137b4f6074" providerId="LiveId" clId="{3CAB8FB7-30D4-4B0A-B34F-79343C8F4340}" dt="2026-03-29T21:22:02.603" v="291" actId="18131"/>
+          <ac:picMkLst>
+            <pc:docMk/>
+            <pc:sldMk cId="2882937987" sldId="270"/>
+            <ac:picMk id="21" creationId="{6192E54A-3709-0C26-1D9F-BD2117D0919B}"/>
+          </ac:picMkLst>
+        </pc:picChg>
+        <pc:picChg chg="mod modCrop">
+          <ac:chgData name="Víctor Issa García" userId="8e09f2137b4f6074" providerId="LiveId" clId="{3CAB8FB7-30D4-4B0A-B34F-79343C8F4340}" dt="2026-03-29T21:22:10.061" v="292" actId="18131"/>
+          <ac:picMkLst>
+            <pc:docMk/>
+            <pc:sldMk cId="2882937987" sldId="270"/>
+            <ac:picMk id="23" creationId="{715329C3-01CA-8175-B9B6-3F17C94BB635}"/>
+          </ac:picMkLst>
+        </pc:picChg>
+        <pc:picChg chg="mod modCrop">
+          <ac:chgData name="Víctor Issa García" userId="8e09f2137b4f6074" providerId="LiveId" clId="{3CAB8FB7-30D4-4B0A-B34F-79343C8F4340}" dt="2026-03-29T21:22:18.843" v="293" actId="18131"/>
+          <ac:picMkLst>
+            <pc:docMk/>
+            <pc:sldMk cId="2882937987" sldId="270"/>
+            <ac:picMk id="27" creationId="{E49DB1BC-281C-4553-C48B-F569B8E4AD9E}"/>
+          </ac:picMkLst>
+        </pc:picChg>
+        <pc:picChg chg="mod modCrop">
+          <ac:chgData name="Víctor Issa García" userId="8e09f2137b4f6074" providerId="LiveId" clId="{3CAB8FB7-30D4-4B0A-B34F-79343C8F4340}" dt="2026-03-29T21:22:45.877" v="296" actId="1076"/>
+          <ac:picMkLst>
+            <pc:docMk/>
+            <pc:sldMk cId="2882937987" sldId="270"/>
+            <ac:picMk id="29" creationId="{409A410A-9865-2387-E26D-A9AD53AC5913}"/>
+          </ac:picMkLst>
+        </pc:picChg>
+        <pc:picChg chg="mod modCrop">
+          <ac:chgData name="Víctor Issa García" userId="8e09f2137b4f6074" providerId="LiveId" clId="{3CAB8FB7-30D4-4B0A-B34F-79343C8F4340}" dt="2026-03-29T21:22:48.895" v="297" actId="1076"/>
+          <ac:picMkLst>
+            <pc:docMk/>
+            <pc:sldMk cId="2882937987" sldId="270"/>
+            <ac:picMk id="31" creationId="{55E84A08-59E5-4B7C-D578-F79E39A89533}"/>
+          </ac:picMkLst>
+        </pc:picChg>
+      </pc:sldChg>
+      <pc:sldChg chg="new del">
+        <pc:chgData name="Víctor Issa García" userId="8e09f2137b4f6074" providerId="LiveId" clId="{3CAB8FB7-30D4-4B0A-B34F-79343C8F4340}" dt="2026-03-29T21:23:57.952" v="300" actId="47"/>
+        <pc:sldMkLst>
+          <pc:docMk/>
+          <pc:sldMk cId="4008394866" sldId="271"/>
+        </pc:sldMkLst>
+      </pc:sldChg>
+      <pc:sldChg chg="delSp add mod">
+        <pc:chgData name="Víctor Issa García" userId="8e09f2137b4f6074" providerId="LiveId" clId="{3CAB8FB7-30D4-4B0A-B34F-79343C8F4340}" dt="2026-03-29T21:24:14.848" v="301" actId="478"/>
+        <pc:sldMkLst>
+          <pc:docMk/>
+          <pc:sldMk cId="4162782218" sldId="272"/>
+        </pc:sldMkLst>
+        <pc:spChg chg="del">
+          <ac:chgData name="Víctor Issa García" userId="8e09f2137b4f6074" providerId="LiveId" clId="{3CAB8FB7-30D4-4B0A-B34F-79343C8F4340}" dt="2026-03-29T21:24:14.848" v="301" actId="478"/>
+          <ac:spMkLst>
+            <pc:docMk/>
+            <pc:sldMk cId="4162782218" sldId="272"/>
+            <ac:spMk id="18" creationId="{9AC01599-C289-2A71-FD4C-AEB776264392}"/>
+          </ac:spMkLst>
+        </pc:spChg>
       </pc:sldChg>
     </pc:docChg>
   </pc:docChgLst>
@@ -4502,6 +4732,750 @@
     <p:extLst>
       <p:ext uri="{BB962C8B-B14F-4D97-AF65-F5344CB8AC3E}">
         <p14:creationId xmlns:p14="http://schemas.microsoft.com/office/powerpoint/2010/main" val="3070418749"/>
+      </p:ext>
+    </p:extLst>
+  </p:cSld>
+  <p:clrMapOvr>
+    <a:masterClrMapping/>
+  </p:clrMapOvr>
+</p:sld>
+</file>
+
+<file path=ppt/slides/slide11.xml><?xml version="1.0" encoding="utf-8"?>
+<p:sld xmlns:a="http://schemas.openxmlformats.org/drawingml/2006/main" xmlns:r="http://schemas.openxmlformats.org/officeDocument/2006/relationships" xmlns:p="http://schemas.openxmlformats.org/presentationml/2006/main">
+  <p:cSld>
+    <p:spTree>
+      <p:nvGrpSpPr>
+        <p:cNvPr id="1" name=""/>
+        <p:cNvGrpSpPr/>
+        <p:nvPr/>
+      </p:nvGrpSpPr>
+      <p:grpSpPr>
+        <a:xfrm>
+          <a:off x="0" y="0"/>
+          <a:ext cx="0" cy="0"/>
+          <a:chOff x="0" y="0"/>
+          <a:chExt cx="0" cy="0"/>
+        </a:xfrm>
+      </p:grpSpPr>
+      <p:sp>
+        <p:nvSpPr>
+          <p:cNvPr id="2" name="Title 1">
+            <a:extLst>
+              <a:ext uri="{FF2B5EF4-FFF2-40B4-BE49-F238E27FC236}">
+                <a16:creationId xmlns:a16="http://schemas.microsoft.com/office/drawing/2014/main" id="{CC85011F-4504-4EC7-D056-AD7521381717}"/>
+              </a:ext>
+            </a:extLst>
+          </p:cNvPr>
+          <p:cNvSpPr>
+            <a:spLocks noGrp="1"/>
+          </p:cNvSpPr>
+          <p:nvPr>
+            <p:ph type="title"/>
+          </p:nvPr>
+        </p:nvSpPr>
+        <p:spPr/>
+        <p:txBody>
+          <a:bodyPr/>
+          <a:lstStyle/>
+          <a:p>
+            <a:endParaRPr lang="en-US" dirty="0"/>
+          </a:p>
+        </p:txBody>
+      </p:sp>
+      <p:pic>
+        <p:nvPicPr>
+          <p:cNvPr id="19" name="Picture 18">
+            <a:extLst>
+              <a:ext uri="{FF2B5EF4-FFF2-40B4-BE49-F238E27FC236}">
+                <a16:creationId xmlns:a16="http://schemas.microsoft.com/office/drawing/2014/main" id="{12F6FD37-1893-1BA7-F482-54CB081A55B0}"/>
+              </a:ext>
+            </a:extLst>
+          </p:cNvPr>
+          <p:cNvPicPr>
+            <a:picLocks noChangeAspect="1"/>
+          </p:cNvPicPr>
+          <p:nvPr/>
+        </p:nvPicPr>
+        <p:blipFill>
+          <a:blip r:embed="rId2">
+            <a:extLst>
+              <a:ext uri="{28A0092B-C50C-407E-A947-70E740481C1C}">
+                <a14:useLocalDpi xmlns:a14="http://schemas.microsoft.com/office/drawing/2010/main" val="0"/>
+              </a:ext>
+            </a:extLst>
+          </a:blip>
+          <a:srcRect l="11240" t="16308" r="51154" b="18817"/>
+          <a:stretch>
+            <a:fillRect/>
+          </a:stretch>
+        </p:blipFill>
+        <p:spPr>
+          <a:xfrm>
+            <a:off x="1676670" y="223684"/>
+            <a:ext cx="3096727" cy="3205316"/>
+          </a:xfrm>
+          <a:prstGeom prst="rect">
+            <a:avLst/>
+          </a:prstGeom>
+        </p:spPr>
+      </p:pic>
+      <p:pic>
+        <p:nvPicPr>
+          <p:cNvPr id="21" name="Picture 20">
+            <a:extLst>
+              <a:ext uri="{FF2B5EF4-FFF2-40B4-BE49-F238E27FC236}">
+                <a16:creationId xmlns:a16="http://schemas.microsoft.com/office/drawing/2014/main" id="{0AC8E1AE-5225-51D7-C286-CB2774B6A2DB}"/>
+              </a:ext>
+            </a:extLst>
+          </p:cNvPr>
+          <p:cNvPicPr>
+            <a:picLocks noChangeAspect="1"/>
+          </p:cNvPicPr>
+          <p:nvPr/>
+        </p:nvPicPr>
+        <p:blipFill>
+          <a:blip r:embed="rId3">
+            <a:extLst>
+              <a:ext uri="{28A0092B-C50C-407E-A947-70E740481C1C}">
+                <a14:useLocalDpi xmlns:a14="http://schemas.microsoft.com/office/drawing/2010/main" val="0"/>
+              </a:ext>
+            </a:extLst>
+          </a:blip>
+          <a:srcRect l="11549" t="16308" r="50845" b="18817"/>
+          <a:stretch>
+            <a:fillRect/>
+          </a:stretch>
+        </p:blipFill>
+        <p:spPr>
+          <a:xfrm>
+            <a:off x="4692580" y="223684"/>
+            <a:ext cx="3096727" cy="3205316"/>
+          </a:xfrm>
+          <a:prstGeom prst="rect">
+            <a:avLst/>
+          </a:prstGeom>
+        </p:spPr>
+      </p:pic>
+      <p:pic>
+        <p:nvPicPr>
+          <p:cNvPr id="23" name="Picture 22">
+            <a:extLst>
+              <a:ext uri="{FF2B5EF4-FFF2-40B4-BE49-F238E27FC236}">
+                <a16:creationId xmlns:a16="http://schemas.microsoft.com/office/drawing/2014/main" id="{6F78FBAF-EC5C-7871-A8C3-626E404ADC53}"/>
+              </a:ext>
+            </a:extLst>
+          </p:cNvPr>
+          <p:cNvPicPr>
+            <a:picLocks noChangeAspect="1"/>
+          </p:cNvPicPr>
+          <p:nvPr/>
+        </p:nvPicPr>
+        <p:blipFill>
+          <a:blip r:embed="rId4">
+            <a:extLst>
+              <a:ext uri="{28A0092B-C50C-407E-A947-70E740481C1C}">
+                <a14:useLocalDpi xmlns:a14="http://schemas.microsoft.com/office/drawing/2010/main" val="0"/>
+              </a:ext>
+            </a:extLst>
+          </a:blip>
+          <a:srcRect l="12065" t="16308" r="51342" b="18817"/>
+          <a:stretch>
+            <a:fillRect/>
+          </a:stretch>
+        </p:blipFill>
+        <p:spPr>
+          <a:xfrm>
+            <a:off x="7659329" y="223684"/>
+            <a:ext cx="3013339" cy="3205316"/>
+          </a:xfrm>
+          <a:prstGeom prst="rect">
+            <a:avLst/>
+          </a:prstGeom>
+        </p:spPr>
+      </p:pic>
+      <p:pic>
+        <p:nvPicPr>
+          <p:cNvPr id="27" name="Picture 26">
+            <a:extLst>
+              <a:ext uri="{FF2B5EF4-FFF2-40B4-BE49-F238E27FC236}">
+                <a16:creationId xmlns:a16="http://schemas.microsoft.com/office/drawing/2014/main" id="{E756990E-3B42-0458-273F-E5455A9DAB4D}"/>
+              </a:ext>
+            </a:extLst>
+          </p:cNvPr>
+          <p:cNvPicPr>
+            <a:picLocks noChangeAspect="1"/>
+          </p:cNvPicPr>
+          <p:nvPr/>
+        </p:nvPicPr>
+        <p:blipFill>
+          <a:blip r:embed="rId5">
+            <a:extLst>
+              <a:ext uri="{28A0092B-C50C-407E-A947-70E740481C1C}">
+                <a14:useLocalDpi xmlns:a14="http://schemas.microsoft.com/office/drawing/2010/main" val="0"/>
+              </a:ext>
+            </a:extLst>
+          </a:blip>
+          <a:srcRect l="11828" t="16891" r="50889" b="18773"/>
+          <a:stretch>
+            <a:fillRect/>
+          </a:stretch>
+        </p:blipFill>
+        <p:spPr>
+          <a:xfrm>
+            <a:off x="1676671" y="3429001"/>
+            <a:ext cx="3095764" cy="3205316"/>
+          </a:xfrm>
+          <a:prstGeom prst="rect">
+            <a:avLst/>
+          </a:prstGeom>
+        </p:spPr>
+      </p:pic>
+      <p:pic>
+        <p:nvPicPr>
+          <p:cNvPr id="29" name="Picture 28">
+            <a:extLst>
+              <a:ext uri="{FF2B5EF4-FFF2-40B4-BE49-F238E27FC236}">
+                <a16:creationId xmlns:a16="http://schemas.microsoft.com/office/drawing/2014/main" id="{9253CE9F-69E0-6386-F73A-F15B4846F69D}"/>
+              </a:ext>
+            </a:extLst>
+          </p:cNvPr>
+          <p:cNvPicPr>
+            <a:picLocks noChangeAspect="1"/>
+          </p:cNvPicPr>
+          <p:nvPr/>
+        </p:nvPicPr>
+        <p:blipFill>
+          <a:blip r:embed="rId6">
+            <a:extLst>
+              <a:ext uri="{28A0092B-C50C-407E-A947-70E740481C1C}">
+                <a14:useLocalDpi xmlns:a14="http://schemas.microsoft.com/office/drawing/2010/main" val="0"/>
+              </a:ext>
+            </a:extLst>
+          </a:blip>
+          <a:srcRect l="11828" t="16354" r="51936" b="19130"/>
+          <a:stretch>
+            <a:fillRect/>
+          </a:stretch>
+        </p:blipFill>
+        <p:spPr>
+          <a:xfrm>
+            <a:off x="4692580" y="3399503"/>
+            <a:ext cx="3013339" cy="3218996"/>
+          </a:xfrm>
+          <a:prstGeom prst="rect">
+            <a:avLst/>
+          </a:prstGeom>
+        </p:spPr>
+      </p:pic>
+      <p:pic>
+        <p:nvPicPr>
+          <p:cNvPr id="31" name="Picture 30">
+            <a:extLst>
+              <a:ext uri="{FF2B5EF4-FFF2-40B4-BE49-F238E27FC236}">
+                <a16:creationId xmlns:a16="http://schemas.microsoft.com/office/drawing/2014/main" id="{86DB7AA0-4E41-1765-C100-E47509EE4AC9}"/>
+              </a:ext>
+            </a:extLst>
+          </p:cNvPr>
+          <p:cNvPicPr>
+            <a:picLocks noChangeAspect="1"/>
+          </p:cNvPicPr>
+          <p:nvPr/>
+        </p:nvPicPr>
+        <p:blipFill>
+          <a:blip r:embed="rId7">
+            <a:extLst>
+              <a:ext uri="{28A0092B-C50C-407E-A947-70E740481C1C}">
+                <a14:useLocalDpi xmlns:a14="http://schemas.microsoft.com/office/drawing/2010/main" val="0"/>
+              </a:ext>
+            </a:extLst>
+          </a:blip>
+          <a:srcRect l="11613" t="16532" r="50912" b="18773"/>
+          <a:stretch>
+            <a:fillRect/>
+          </a:stretch>
+        </p:blipFill>
+        <p:spPr>
+          <a:xfrm>
+            <a:off x="7705919" y="3399504"/>
+            <a:ext cx="3094496" cy="3205316"/>
+          </a:xfrm>
+          <a:prstGeom prst="rect">
+            <a:avLst/>
+          </a:prstGeom>
+        </p:spPr>
+      </p:pic>
+    </p:spTree>
+    <p:extLst>
+      <p:ext uri="{BB962C8B-B14F-4D97-AF65-F5344CB8AC3E}">
+        <p14:creationId xmlns:p14="http://schemas.microsoft.com/office/powerpoint/2010/main" val="2985895534"/>
+      </p:ext>
+    </p:extLst>
+  </p:cSld>
+  <p:clrMapOvr>
+    <a:masterClrMapping/>
+  </p:clrMapOvr>
+</p:sld>
+</file>
+
+<file path=ppt/slides/slide12.xml><?xml version="1.0" encoding="utf-8"?>
+<p:sld xmlns:a="http://schemas.openxmlformats.org/drawingml/2006/main" xmlns:r="http://schemas.openxmlformats.org/officeDocument/2006/relationships" xmlns:p="http://schemas.openxmlformats.org/presentationml/2006/main">
+  <p:cSld>
+    <p:spTree>
+      <p:nvGrpSpPr>
+        <p:cNvPr id="1" name="">
+          <a:extLst>
+            <a:ext uri="{FF2B5EF4-FFF2-40B4-BE49-F238E27FC236}">
+              <a16:creationId xmlns:a16="http://schemas.microsoft.com/office/drawing/2014/main" id="{17E78A48-1C0D-78AB-F326-DEAF1264EED6}"/>
+            </a:ext>
+          </a:extLst>
+        </p:cNvPr>
+        <p:cNvGrpSpPr/>
+        <p:nvPr/>
+      </p:nvGrpSpPr>
+      <p:grpSpPr>
+        <a:xfrm>
+          <a:off x="0" y="0"/>
+          <a:ext cx="0" cy="0"/>
+          <a:chOff x="0" y="0"/>
+          <a:chExt cx="0" cy="0"/>
+        </a:xfrm>
+      </p:grpSpPr>
+      <p:sp>
+        <p:nvSpPr>
+          <p:cNvPr id="2" name="Title 1">
+            <a:extLst>
+              <a:ext uri="{FF2B5EF4-FFF2-40B4-BE49-F238E27FC236}">
+                <a16:creationId xmlns:a16="http://schemas.microsoft.com/office/drawing/2014/main" id="{744BA400-E2DC-B2ED-88AE-B961A4D8AFE4}"/>
+              </a:ext>
+            </a:extLst>
+          </p:cNvPr>
+          <p:cNvSpPr>
+            <a:spLocks noGrp="1"/>
+          </p:cNvSpPr>
+          <p:nvPr>
+            <p:ph type="title"/>
+          </p:nvPr>
+        </p:nvSpPr>
+        <p:spPr/>
+        <p:txBody>
+          <a:bodyPr/>
+          <a:lstStyle/>
+          <a:p>
+            <a:endParaRPr lang="en-US" dirty="0"/>
+          </a:p>
+        </p:txBody>
+      </p:sp>
+      <p:pic>
+        <p:nvPicPr>
+          <p:cNvPr id="19" name="Picture 18">
+            <a:extLst>
+              <a:ext uri="{FF2B5EF4-FFF2-40B4-BE49-F238E27FC236}">
+                <a16:creationId xmlns:a16="http://schemas.microsoft.com/office/drawing/2014/main" id="{81D66F95-BA91-1151-33C6-A24229929B32}"/>
+              </a:ext>
+            </a:extLst>
+          </p:cNvPr>
+          <p:cNvPicPr>
+            <a:picLocks noChangeAspect="1"/>
+          </p:cNvPicPr>
+          <p:nvPr/>
+        </p:nvPicPr>
+        <p:blipFill>
+          <a:blip r:embed="rId2">
+            <a:extLst>
+              <a:ext uri="{28A0092B-C50C-407E-A947-70E740481C1C}">
+                <a14:useLocalDpi xmlns:a14="http://schemas.microsoft.com/office/drawing/2010/main" val="0"/>
+              </a:ext>
+            </a:extLst>
+          </a:blip>
+          <a:srcRect l="54343" t="15711" r="8051" b="19414"/>
+          <a:stretch>
+            <a:fillRect/>
+          </a:stretch>
+        </p:blipFill>
+        <p:spPr>
+          <a:xfrm>
+            <a:off x="1676670" y="223684"/>
+            <a:ext cx="3096727" cy="3205316"/>
+          </a:xfrm>
+          <a:prstGeom prst="rect">
+            <a:avLst/>
+          </a:prstGeom>
+        </p:spPr>
+      </p:pic>
+      <p:pic>
+        <p:nvPicPr>
+          <p:cNvPr id="21" name="Picture 20">
+            <a:extLst>
+              <a:ext uri="{FF2B5EF4-FFF2-40B4-BE49-F238E27FC236}">
+                <a16:creationId xmlns:a16="http://schemas.microsoft.com/office/drawing/2014/main" id="{6192E54A-3709-0C26-1D9F-BD2117D0919B}"/>
+              </a:ext>
+            </a:extLst>
+          </p:cNvPr>
+          <p:cNvPicPr>
+            <a:picLocks noChangeAspect="1"/>
+          </p:cNvPicPr>
+          <p:nvPr/>
+        </p:nvPicPr>
+        <p:blipFill>
+          <a:blip r:embed="rId3">
+            <a:extLst>
+              <a:ext uri="{28A0092B-C50C-407E-A947-70E740481C1C}">
+                <a14:useLocalDpi xmlns:a14="http://schemas.microsoft.com/office/drawing/2010/main" val="0"/>
+              </a:ext>
+            </a:extLst>
+          </a:blip>
+          <a:srcRect l="54175" t="15711" r="8219" b="19414"/>
+          <a:stretch>
+            <a:fillRect/>
+          </a:stretch>
+        </p:blipFill>
+        <p:spPr>
+          <a:xfrm>
+            <a:off x="4692580" y="223684"/>
+            <a:ext cx="3096727" cy="3205316"/>
+          </a:xfrm>
+          <a:prstGeom prst="rect">
+            <a:avLst/>
+          </a:prstGeom>
+        </p:spPr>
+      </p:pic>
+      <p:pic>
+        <p:nvPicPr>
+          <p:cNvPr id="23" name="Picture 22">
+            <a:extLst>
+              <a:ext uri="{FF2B5EF4-FFF2-40B4-BE49-F238E27FC236}">
+                <a16:creationId xmlns:a16="http://schemas.microsoft.com/office/drawing/2014/main" id="{715329C3-01CA-8175-B9B6-3F17C94BB635}"/>
+              </a:ext>
+            </a:extLst>
+          </p:cNvPr>
+          <p:cNvPicPr>
+            <a:picLocks noChangeAspect="1"/>
+          </p:cNvPicPr>
+          <p:nvPr/>
+        </p:nvPicPr>
+        <p:blipFill>
+          <a:blip r:embed="rId4">
+            <a:extLst>
+              <a:ext uri="{28A0092B-C50C-407E-A947-70E740481C1C}">
+                <a14:useLocalDpi xmlns:a14="http://schemas.microsoft.com/office/drawing/2010/main" val="0"/>
+              </a:ext>
+            </a:extLst>
+          </a:blip>
+          <a:srcRect l="53855" t="15512" r="9552" b="19613"/>
+          <a:stretch>
+            <a:fillRect/>
+          </a:stretch>
+        </p:blipFill>
+        <p:spPr>
+          <a:xfrm>
+            <a:off x="7659329" y="223684"/>
+            <a:ext cx="3013339" cy="3205316"/>
+          </a:xfrm>
+          <a:prstGeom prst="rect">
+            <a:avLst/>
+          </a:prstGeom>
+        </p:spPr>
+      </p:pic>
+      <p:pic>
+        <p:nvPicPr>
+          <p:cNvPr id="27" name="Picture 26">
+            <a:extLst>
+              <a:ext uri="{FF2B5EF4-FFF2-40B4-BE49-F238E27FC236}">
+                <a16:creationId xmlns:a16="http://schemas.microsoft.com/office/drawing/2014/main" id="{E49DB1BC-281C-4553-C48B-F569B8E4AD9E}"/>
+              </a:ext>
+            </a:extLst>
+          </p:cNvPr>
+          <p:cNvPicPr>
+            <a:picLocks noChangeAspect="1"/>
+          </p:cNvPicPr>
+          <p:nvPr/>
+        </p:nvPicPr>
+        <p:blipFill>
+          <a:blip r:embed="rId5">
+            <a:extLst>
+              <a:ext uri="{28A0092B-C50C-407E-A947-70E740481C1C}">
+                <a14:useLocalDpi xmlns:a14="http://schemas.microsoft.com/office/drawing/2010/main" val="0"/>
+              </a:ext>
+            </a:extLst>
+          </a:blip>
+          <a:srcRect l="53433" t="16299" r="9284" b="19365"/>
+          <a:stretch>
+            <a:fillRect/>
+          </a:stretch>
+        </p:blipFill>
+        <p:spPr>
+          <a:xfrm>
+            <a:off x="1676671" y="3429001"/>
+            <a:ext cx="3095764" cy="3205316"/>
+          </a:xfrm>
+          <a:prstGeom prst="rect">
+            <a:avLst/>
+          </a:prstGeom>
+        </p:spPr>
+      </p:pic>
+      <p:pic>
+        <p:nvPicPr>
+          <p:cNvPr id="29" name="Picture 28">
+            <a:extLst>
+              <a:ext uri="{FF2B5EF4-FFF2-40B4-BE49-F238E27FC236}">
+                <a16:creationId xmlns:a16="http://schemas.microsoft.com/office/drawing/2014/main" id="{409A410A-9865-2387-E26D-A9AD53AC5913}"/>
+              </a:ext>
+            </a:extLst>
+          </p:cNvPr>
+          <p:cNvPicPr>
+            <a:picLocks noChangeAspect="1"/>
+          </p:cNvPicPr>
+          <p:nvPr/>
+        </p:nvPicPr>
+        <p:blipFill>
+          <a:blip r:embed="rId6">
+            <a:extLst>
+              <a:ext uri="{28A0092B-C50C-407E-A947-70E740481C1C}">
+                <a14:useLocalDpi xmlns:a14="http://schemas.microsoft.com/office/drawing/2010/main" val="0"/>
+              </a:ext>
+            </a:extLst>
+          </a:blip>
+          <a:srcRect l="54629" t="15763" r="9135" b="19721"/>
+          <a:stretch>
+            <a:fillRect/>
+          </a:stretch>
+        </p:blipFill>
+        <p:spPr>
+          <a:xfrm>
+            <a:off x="4772435" y="3392664"/>
+            <a:ext cx="3013339" cy="3218996"/>
+          </a:xfrm>
+          <a:prstGeom prst="rect">
+            <a:avLst/>
+          </a:prstGeom>
+        </p:spPr>
+      </p:pic>
+      <p:pic>
+        <p:nvPicPr>
+          <p:cNvPr id="31" name="Picture 30">
+            <a:extLst>
+              <a:ext uri="{FF2B5EF4-FFF2-40B4-BE49-F238E27FC236}">
+                <a16:creationId xmlns:a16="http://schemas.microsoft.com/office/drawing/2014/main" id="{55E84A08-59E5-4B7C-D578-F79E39A89533}"/>
+              </a:ext>
+            </a:extLst>
+          </p:cNvPr>
+          <p:cNvPicPr>
+            <a:picLocks noChangeAspect="1"/>
+          </p:cNvPicPr>
+          <p:nvPr/>
+        </p:nvPicPr>
+        <p:blipFill>
+          <a:blip r:embed="rId7">
+            <a:extLst>
+              <a:ext uri="{28A0092B-C50C-407E-A947-70E740481C1C}">
+                <a14:useLocalDpi xmlns:a14="http://schemas.microsoft.com/office/drawing/2010/main" val="0"/>
+              </a:ext>
+            </a:extLst>
+          </a:blip>
+          <a:srcRect l="54270" t="15539" r="8255" b="19765"/>
+          <a:stretch>
+            <a:fillRect/>
+          </a:stretch>
+        </p:blipFill>
+        <p:spPr>
+          <a:xfrm>
+            <a:off x="7710720" y="3370007"/>
+            <a:ext cx="3094496" cy="3205316"/>
+          </a:xfrm>
+          <a:prstGeom prst="rect">
+            <a:avLst/>
+          </a:prstGeom>
+        </p:spPr>
+      </p:pic>
+    </p:spTree>
+    <p:extLst>
+      <p:ext uri="{BB962C8B-B14F-4D97-AF65-F5344CB8AC3E}">
+        <p14:creationId xmlns:p14="http://schemas.microsoft.com/office/powerpoint/2010/main" val="2882937987"/>
+      </p:ext>
+    </p:extLst>
+  </p:cSld>
+  <p:clrMapOvr>
+    <a:masterClrMapping/>
+  </p:clrMapOvr>
+</p:sld>
+</file>
+
+<file path=ppt/slides/slide13.xml><?xml version="1.0" encoding="utf-8"?>
+<p:sld xmlns:a="http://schemas.openxmlformats.org/drawingml/2006/main" xmlns:r="http://schemas.openxmlformats.org/officeDocument/2006/relationships" xmlns:p="http://schemas.openxmlformats.org/presentationml/2006/main">
+  <p:cSld>
+    <p:spTree>
+      <p:nvGrpSpPr>
+        <p:cNvPr id="1" name="">
+          <a:extLst>
+            <a:ext uri="{FF2B5EF4-FFF2-40B4-BE49-F238E27FC236}">
+              <a16:creationId xmlns:a16="http://schemas.microsoft.com/office/drawing/2014/main" id="{CA4EA2BC-C671-B1D6-4E10-29B4C65D7F1B}"/>
+            </a:ext>
+          </a:extLst>
+        </p:cNvPr>
+        <p:cNvGrpSpPr/>
+        <p:nvPr/>
+      </p:nvGrpSpPr>
+      <p:grpSpPr>
+        <a:xfrm>
+          <a:off x="0" y="0"/>
+          <a:ext cx="0" cy="0"/>
+          <a:chOff x="0" y="0"/>
+          <a:chExt cx="0" cy="0"/>
+        </a:xfrm>
+      </p:grpSpPr>
+      <p:sp>
+        <p:nvSpPr>
+          <p:cNvPr id="2" name="Title 1">
+            <a:extLst>
+              <a:ext uri="{FF2B5EF4-FFF2-40B4-BE49-F238E27FC236}">
+                <a16:creationId xmlns:a16="http://schemas.microsoft.com/office/drawing/2014/main" id="{891B4768-E34A-6F04-9AAA-285F99BA6D3F}"/>
+              </a:ext>
+            </a:extLst>
+          </p:cNvPr>
+          <p:cNvSpPr>
+            <a:spLocks noGrp="1"/>
+          </p:cNvSpPr>
+          <p:nvPr>
+            <p:ph type="title"/>
+          </p:nvPr>
+        </p:nvSpPr>
+        <p:spPr>
+          <a:xfrm>
+            <a:off x="6944033" y="365124"/>
+            <a:ext cx="6221361" cy="1325563"/>
+          </a:xfrm>
+        </p:spPr>
+        <p:txBody>
+          <a:bodyPr/>
+          <a:lstStyle/>
+          <a:p>
+            <a:r>
+              <a:rPr lang="en-US" dirty="0"/>
+              <a:t>Mean absolute error</a:t>
+            </a:r>
+            <a:br>
+              <a:rPr lang="en-US" dirty="0"/>
+            </a:br>
+            <a:r>
+              <a:rPr lang="en-US" dirty="0"/>
+              <a:t>0.078</a:t>
+            </a:r>
+          </a:p>
+        </p:txBody>
+      </p:sp>
+      <p:pic>
+        <p:nvPicPr>
+          <p:cNvPr id="7" name="Content Placeholder 3">
+            <a:extLst>
+              <a:ext uri="{FF2B5EF4-FFF2-40B4-BE49-F238E27FC236}">
+                <a16:creationId xmlns:a16="http://schemas.microsoft.com/office/drawing/2014/main" id="{D5A95A7D-9013-C945-B569-3A012593C460}"/>
+              </a:ext>
+            </a:extLst>
+          </p:cNvPr>
+          <p:cNvPicPr>
+            <a:picLocks noChangeAspect="1"/>
+          </p:cNvPicPr>
+          <p:nvPr/>
+        </p:nvPicPr>
+        <p:blipFill>
+          <a:blip r:embed="rId2">
+            <a:extLst>
+              <a:ext uri="{28A0092B-C50C-407E-A947-70E740481C1C}">
+                <a14:useLocalDpi xmlns:a14="http://schemas.microsoft.com/office/drawing/2010/main" val="0"/>
+              </a:ext>
+            </a:extLst>
+          </a:blip>
+          <a:stretch>
+            <a:fillRect/>
+          </a:stretch>
+        </p:blipFill>
+        <p:spPr>
+          <a:xfrm>
+            <a:off x="-713775" y="-484982"/>
+            <a:ext cx="7252229" cy="4351338"/>
+          </a:xfrm>
+          <a:prstGeom prst="rect">
+            <a:avLst/>
+          </a:prstGeom>
+        </p:spPr>
+      </p:pic>
+      <p:pic>
+        <p:nvPicPr>
+          <p:cNvPr id="13" name="Content Placeholder 9">
+            <a:extLst>
+              <a:ext uri="{FF2B5EF4-FFF2-40B4-BE49-F238E27FC236}">
+                <a16:creationId xmlns:a16="http://schemas.microsoft.com/office/drawing/2014/main" id="{54CF005A-F39C-5A74-8CFA-673BF705205A}"/>
+              </a:ext>
+            </a:extLst>
+          </p:cNvPr>
+          <p:cNvPicPr>
+            <a:picLocks noChangeAspect="1"/>
+          </p:cNvPicPr>
+          <p:nvPr/>
+        </p:nvPicPr>
+        <p:blipFill>
+          <a:blip r:embed="rId3">
+            <a:extLst>
+              <a:ext uri="{28A0092B-C50C-407E-A947-70E740481C1C}">
+                <a14:useLocalDpi xmlns:a14="http://schemas.microsoft.com/office/drawing/2010/main" val="0"/>
+              </a:ext>
+            </a:extLst>
+          </a:blip>
+          <a:stretch>
+            <a:fillRect/>
+          </a:stretch>
+        </p:blipFill>
+        <p:spPr>
+          <a:xfrm>
+            <a:off x="98317" y="3200393"/>
+            <a:ext cx="5486411" cy="3657607"/>
+          </a:xfrm>
+          <a:prstGeom prst="rect">
+            <a:avLst/>
+          </a:prstGeom>
+        </p:spPr>
+      </p:pic>
+      <p:pic>
+        <p:nvPicPr>
+          <p:cNvPr id="19" name="Content Placeholder 15">
+            <a:extLst>
+              <a:ext uri="{FF2B5EF4-FFF2-40B4-BE49-F238E27FC236}">
+                <a16:creationId xmlns:a16="http://schemas.microsoft.com/office/drawing/2014/main" id="{EAC5D253-7E53-1111-7F02-4B2937E9F277}"/>
+              </a:ext>
+            </a:extLst>
+          </p:cNvPr>
+          <p:cNvPicPr>
+            <a:picLocks noChangeAspect="1"/>
+          </p:cNvPicPr>
+          <p:nvPr/>
+        </p:nvPicPr>
+        <p:blipFill>
+          <a:blip r:embed="rId4">
+            <a:extLst>
+              <a:ext uri="{28A0092B-C50C-407E-A947-70E740481C1C}">
+                <a14:useLocalDpi xmlns:a14="http://schemas.microsoft.com/office/drawing/2010/main" val="0"/>
+              </a:ext>
+            </a:extLst>
+          </a:blip>
+          <a:stretch>
+            <a:fillRect/>
+          </a:stretch>
+        </p:blipFill>
+        <p:spPr>
+          <a:xfrm>
+            <a:off x="5820708" y="1873660"/>
+            <a:ext cx="6827273" cy="5120455"/>
+          </a:xfrm>
+          <a:prstGeom prst="rect">
+            <a:avLst/>
+          </a:prstGeom>
+        </p:spPr>
+      </p:pic>
+    </p:spTree>
+    <p:extLst>
+      <p:ext uri="{BB962C8B-B14F-4D97-AF65-F5344CB8AC3E}">
+        <p14:creationId xmlns:p14="http://schemas.microsoft.com/office/powerpoint/2010/main" val="4162782218"/>
       </p:ext>
     </p:extLst>
   </p:cSld>

</xml_diff>